<commit_message>
The generated deck was the one place the test count could still drift
test_the_documented_test_counts_are_the_real_ones held README.md, HANDOFF.md and
ci.yml to one number, and the submitted deck to none — so this commit's own
predecessor left docs/HackSummit-PACT.pptx claiming 190 while the suite collected
194. The deck exists as a generator precisely so a number moving in the
repository can be carried into it without opening PowerPoint, and that only
works if something notices when one moves. It is also the artifact a judge
actually reads.

Both claims in it are now asserted: the proof chip on slide 1 and the CI line.
Mutation checked — reverting the chip to 190 fails the suite by name.

Deck regenerated so the committed bytes match the generator. Also removes the
LibreOffice lock file that had been sitting in docs/ untracked.
</commit_message>
<xml_diff>
--- a/docs/HackSummit-PACT.pptx
+++ b/docs/HackSummit-PACT.pptx
@@ -3399,7 +3399,7 @@
                 </a:solidFill>
                 <a:latin typeface="Arial"/>
               </a:rPr>
-              <a:t>190 + 55 tests, green on every push</a:t>
+              <a:t>194 + 55 tests, green on every push</a:t>
             </a:r>
           </a:p>
         </p:txBody>
@@ -5789,7 +5789,7 @@
                 </a:solidFill>
                 <a:latin typeface="Arial"/>
               </a:rPr>
-              <a:t>190 Python tests, 55 console tests, and the six demo beats run against the image itself on every push.</a:t>
+              <a:t>194 Python tests, 55 console tests, and the six demo beats run against the image itself on every push.</a:t>
             </a:r>
           </a:p>
         </p:txBody>
@@ -8517,7 +8517,7 @@
                 </a:solidFill>
                 <a:latin typeface="Arial"/>
               </a:rPr>
-              <a:t>Three lanes, one repository, 84 commits on main — backend, evidence and interfaces, each with its own directory and its own tests.</a:t>
+              <a:t>Three lanes, one repository, 86 commits on main — backend, evidence and interfaces, each with its own directory and its own tests.</a:t>
             </a:r>
           </a:p>
         </p:txBody>

</xml_diff>